<commit_message>
docs: Redacted capitalized Bixah strings from documentation binaries
</commit_message>
<xml_diff>
--- a/SentinURL Final Presentation.pptx
+++ b/SentinURL Final Presentation.pptx
@@ -4458,15 +4458,8 @@
           </a:bodyPr>
           <a:lstStyle/>
           <a:p>
-            <a:pPr algn="ctr">
-              <a:defRPr sz="6000" b="1">
-                <a:solidFill>
-                  <a:srgbClr val="2E74B5"/>
-                </a:solidFill>
-              </a:defRPr>
-            </a:pPr>
-            <a:r>
-              <a:t>BIXAH ULTIMATE</a:t>
+            <a:r>
+              <a:t>SENTINURL</a:t>
             </a:r>
           </a:p>
         </p:txBody>

</xml_diff>